<commit_message>
feat(report): partner deck re-cut on the fix-and-verify exhibits
The deck script embeds the figure PNGs live, so the 2026-09-14 fix-and-verify
regeneration (4422587) had already refreshed every figure slide at build time;
what remained stale were the two hardcoded stat tiles on the title slide.
"366 MW" becomes 356 MW (village solar under the cap at full 8-week
resolution) and "$1.6 M/yr" becomes $2.8 M/yr (the carbon-neutral coordination
value, now an exact LP with no solver gap). Slide count, story order, and the
bare-bones no-caveat format are unchanged — caveats still travel in the spoken
track and RUN_LOG.md.

Verified: rebuilt with pptxgenjs under node v24; the shipped .pptx carries 10
slides, title tiles read 780 / 356 MW / $2.8 M/yr, and all nine embedded
figure PNGs are byte-identical (SHA-1) to the committed results/figures files.

Co-Authored-By: Claude Fable 5 <noreply@anthropic.com>
</commit_message>
<xml_diff>
--- a/results/figures/timor_partner_deck.pptx
+++ b/results/figures/timor_partner_deck.pptx
@@ -1865,7 +1865,7 @@
                 <a:ea typeface="Calibri" pitchFamily="34" charset="-122"/>
                 <a:cs typeface="Calibri" pitchFamily="34" charset="-120"/>
               </a:rPr>
-              <a:t>366 MW</a:t>
+              <a:t>356 MW</a:t>
             </a:r>
             <a:endParaRPr lang="en-US" sz="4000" dirty="0"/>
           </a:p>
@@ -1943,7 +1943,7 @@
                 <a:ea typeface="Calibri" pitchFamily="34" charset="-122"/>
                 <a:cs typeface="Calibri" pitchFamily="34" charset="-120"/>
               </a:rPr>
-              <a:t>$1.6 M/yr</a:t>
+              <a:t>$2.8 M/yr</a:t>
             </a:r>
             <a:endParaRPr lang="en-US" sz="4000" dirty="0"/>
           </a:p>
@@ -2061,7 +2061,7 @@
       </p:sp>
       <p:pic>
         <p:nvPicPr>
-          <p:cNvPr id="3" name="Image 0" descr="/Users/kaarthigeswaranagnapathy/Documents/GitHub/garuda/results/figures/headline_coordination.png">    </p:cNvPr>
+          <p:cNvPr id="3" name="Image 0" descr="/home/pwrlabadmin/garuda/.claude/worktrees/repo-orientation-sync-bd6b46/results/figures/headline_coordination.png">    </p:cNvPr>
           <p:cNvPicPr>
             <a:picLocks noChangeAspect="1"/>
           </p:cNvPicPr>
@@ -2156,7 +2156,7 @@
       </p:sp>
       <p:pic>
         <p:nvPicPr>
-          <p:cNvPr id="3" name="Image 0" descr="/Users/kaarthigeswaranagnapathy/Documents/GitHub/garuda/results/figures/village_map.png">    </p:cNvPr>
+          <p:cNvPr id="3" name="Image 0" descr="/home/pwrlabadmin/garuda/.claude/worktrees/repo-orientation-sync-bd6b46/results/figures/village_map.png">    </p:cNvPr>
           <p:cNvPicPr>
             <a:picLocks noChangeAspect="1"/>
           </p:cNvPicPr>
@@ -2251,7 +2251,7 @@
       </p:sp>
       <p:pic>
         <p:nvPicPr>
-          <p:cNvPr id="3" name="Image 0" descr="/Users/kaarthigeswaranagnapathy/Documents/GitHub/garuda/results/figures/recipe_and_diesel.png">    </p:cNvPr>
+          <p:cNvPr id="3" name="Image 0" descr="/home/pwrlabadmin/garuda/.claude/worktrees/repo-orientation-sync-bd6b46/results/figures/recipe_and_diesel.png">    </p:cNvPr>
           <p:cNvPicPr>
             <a:picLocks noChangeAspect="1"/>
           </p:cNvPicPr>
@@ -2346,7 +2346,7 @@
       </p:sp>
       <p:pic>
         <p:nvPicPr>
-          <p:cNvPr id="3" name="Image 0" descr="/Users/kaarthigeswaranagnapathy/Documents/GitHub/garuda/results/figures/cost_stack.png">    </p:cNvPr>
+          <p:cNvPr id="3" name="Image 0" descr="/home/pwrlabadmin/garuda/.claude/worktrees/repo-orientation-sync-bd6b46/results/figures/cost_stack.png">    </p:cNvPr>
           <p:cNvPicPr>
             <a:picLocks noChangeAspect="1"/>
           </p:cNvPicPr>
@@ -2441,7 +2441,7 @@
       </p:sp>
       <p:pic>
         <p:nvPicPr>
-          <p:cNvPr id="3" name="Image 0" descr="/Users/kaarthigeswaranagnapathy/Documents/GitHub/garuda/results/figures/three_regimes.png">    </p:cNvPr>
+          <p:cNvPr id="3" name="Image 0" descr="/home/pwrlabadmin/garuda/.claude/worktrees/repo-orientation-sync-bd6b46/results/figures/three_regimes.png">    </p:cNvPr>
           <p:cNvPicPr>
             <a:picLocks noChangeAspect="1"/>
           </p:cNvPicPr>
@@ -2536,7 +2536,7 @@
       </p:sp>
       <p:pic>
         <p:nvPicPr>
-          <p:cNvPr id="3" name="Image 0" descr="/Users/kaarthigeswaranagnapathy/Documents/GitHub/garuda/results/figures/solar_buildout.png">    </p:cNvPr>
+          <p:cNvPr id="3" name="Image 0" descr="/home/pwrlabadmin/garuda/.claude/worktrees/repo-orientation-sync-bd6b46/results/figures/solar_buildout.png">    </p:cNvPr>
           <p:cNvPicPr>
             <a:picLocks noChangeAspect="1"/>
           </p:cNvPicPr>
@@ -2631,7 +2631,7 @@
       </p:sp>
       <p:pic>
         <p:nvPicPr>
-          <p:cNvPr id="3" name="Image 0" descr="/Users/kaarthigeswaranagnapathy/Documents/GitHub/garuda/results/figures/village_supply.png">    </p:cNvPr>
+          <p:cNvPr id="3" name="Image 0" descr="/home/pwrlabadmin/garuda/.claude/worktrees/repo-orientation-sync-bd6b46/results/figures/village_supply.png">    </p:cNvPr>
           <p:cNvPicPr>
             <a:picLocks noChangeAspect="1"/>
           </p:cNvPicPr>
@@ -2726,7 +2726,7 @@
       </p:sp>
       <p:pic>
         <p:nvPicPr>
-          <p:cNvPr id="3" name="Image 0" descr="/Users/kaarthigeswaranagnapathy/Documents/GitHub/garuda/results/figures/cost_vs_co2.png">    </p:cNvPr>
+          <p:cNvPr id="3" name="Image 0" descr="/home/pwrlabadmin/garuda/.claude/worktrees/repo-orientation-sync-bd6b46/results/figures/cost_vs_co2.png">    </p:cNvPr>
           <p:cNvPicPr>
             <a:picLocks noChangeAspect="1"/>
           </p:cNvPicPr>
@@ -2821,7 +2821,7 @@
       </p:sp>
       <p:pic>
         <p:nvPicPr>
-          <p:cNvPr id="3" name="Image 0" descr="/Users/kaarthigeswaranagnapathy/Documents/GitHub/garuda/results/figures/connection_map.png">    </p:cNvPr>
+          <p:cNvPr id="3" name="Image 0" descr="/home/pwrlabadmin/garuda/.claude/worktrees/repo-orientation-sync-bd6b46/results/figures/connection_map.png">    </p:cNvPr>
           <p:cNvPicPr>
             <a:picLocks noChangeAspect="1"/>
           </p:cNvPicPr>

</xml_diff>